<commit_message>
Chuleton de referencia y tres capas en cada practica
- chuleton.html: 75 fichas de HTML y CSS repartidas en nueve bloques, cada
  una con lo que hace, TODAS sus opciones listadas, ejemplo copiable y las
  trampas. Buscador que ignora tildes, filtro esenciales/avanzadas y
  plantillas enteras para copiar. Se imprime como dossier.
- Cada practica lleva ahora tres capas: hay que / puedes / podrias, con
  casillas. Sustituyen a las listas antiguas, que decian lo mismo.
- Cajas de herramientas en las practicas de las sesiones 1 y 2: que se
  puede usar en ese momento, en esenciales y avanzadas, con enlace al
  bloque correspondiente del chuleton.
- Los .pptx de respaldo incluyen capas y herramientas.

Co-Authored-By: Claude Opus 5 <noreply@anthropic.com>
</commit_message>
<xml_diff>
--- a/presentaciones/Sesion-3-Publicar.pptx
+++ b/presentaciones/Sesion-3-Publicar.pptx
@@ -4675,193 +4675,391 @@
           <a:p>
             <a:pPr>
               <a:lnSpc>
-                <a:spcPct val="140000"/>
-              </a:lnSpc>
-              <a:spcBef>
-                <a:spcPts val="0"/>
-              </a:spcBef>
-              <a:spcAft>
-                <a:spcPts val="500"/>
-              </a:spcAft>
-            </a:pPr>
-            <a:r>
-              <a:rPr sz="1450" b="0" i="0">
+                <a:spcPct val="117500"/>
+              </a:lnSpc>
+              <a:spcBef>
+                <a:spcPts val="1000"/>
+              </a:spcBef>
+              <a:spcAft>
+                <a:spcPts val="328"/>
+              </a:spcAft>
+            </a:pPr>
+            <a:r>
+              <a:rPr sz="950" b="0" i="0" spc="500">
+                <a:solidFill>
+                  <a:srgbClr val="8A7C14"/>
+                </a:solidFill>
+                <a:latin typeface="Menlo"/>
+              </a:rPr>
+              <a:t>HAY QUE</a:t>
+            </a:r>
+          </a:p>
+          <a:p>
+            <a:pPr>
+              <a:lnSpc>
+                <a:spcPct val="126900"/>
+              </a:lnSpc>
+              <a:spcBef>
+                <a:spcPts val="0"/>
+              </a:spcBef>
+              <a:spcAft>
+                <a:spcPts val="246"/>
+              </a:spcAft>
+            </a:pPr>
+            <a:r>
+              <a:rPr sz="1110" b="0" i="0">
                 <a:solidFill>
                   <a:srgbClr val="444444"/>
                 </a:solidFill>
                 <a:latin typeface="Iowan Old Style"/>
               </a:rPr>
-              <a:t>·  github.com → New repository.</a:t>
-            </a:r>
-          </a:p>
-          <a:p>
-            <a:pPr>
-              <a:lnSpc>
-                <a:spcPct val="140000"/>
-              </a:lnSpc>
-              <a:spcBef>
-                <a:spcPts val="0"/>
-              </a:spcBef>
-              <a:spcAft>
-                <a:spcPts val="500"/>
-              </a:spcAft>
-            </a:pPr>
-            <a:r>
-              <a:rPr sz="1450" b="0" i="0">
+              <a:t>☐  La checklist repasada entera</a:t>
+            </a:r>
+          </a:p>
+          <a:p>
+            <a:pPr>
+              <a:lnSpc>
+                <a:spcPct val="126900"/>
+              </a:lnSpc>
+              <a:spcBef>
+                <a:spcPts val="0"/>
+              </a:spcBef>
+              <a:spcAft>
+                <a:spcPts val="246"/>
+              </a:spcAft>
+            </a:pPr>
+            <a:r>
+              <a:rPr sz="1110" b="0" i="0">
                 <a:solidFill>
                   <a:srgbClr val="444444"/>
                 </a:solidFill>
                 <a:latin typeface="Iowan Old Style"/>
               </a:rPr>
-              <a:t>·  Nombre mi-web, marcar Public, Create.</a:t>
-            </a:r>
-          </a:p>
-          <a:p>
-            <a:pPr>
-              <a:lnSpc>
-                <a:spcPct val="140000"/>
-              </a:lnSpc>
-              <a:spcBef>
-                <a:spcPts val="0"/>
-              </a:spcBef>
-              <a:spcAft>
-                <a:spcPts val="500"/>
-              </a:spcAft>
-            </a:pPr>
-            <a:r>
-              <a:rPr sz="1450" b="0" i="0">
+              <a:t>☐  New repository → nombre → Public</a:t>
+            </a:r>
+          </a:p>
+          <a:p>
+            <a:pPr>
+              <a:lnSpc>
+                <a:spcPct val="126900"/>
+              </a:lnSpc>
+              <a:spcBef>
+                <a:spcPts val="0"/>
+              </a:spcBef>
+              <a:spcAft>
+                <a:spcPts val="246"/>
+              </a:spcAft>
+            </a:pPr>
+            <a:r>
+              <a:rPr sz="1110" b="0" i="0">
                 <a:solidFill>
                   <a:srgbClr val="444444"/>
                 </a:solidFill>
                 <a:latin typeface="Iowan Old Style"/>
               </a:rPr>
-              <a:t>·  uploading an existing file.</a:t>
-            </a:r>
-          </a:p>
-          <a:p>
-            <a:pPr>
-              <a:lnSpc>
-                <a:spcPct val="140000"/>
-              </a:lnSpc>
-              <a:spcBef>
-                <a:spcPts val="0"/>
-              </a:spcBef>
-              <a:spcAft>
-                <a:spcPts val="500"/>
-              </a:spcAft>
-            </a:pPr>
-            <a:r>
-              <a:rPr sz="1450" b="0" i="0">
+              <a:t>☐  Arrastrar el contenido, no la carpeta</a:t>
+            </a:r>
+          </a:p>
+          <a:p>
+            <a:pPr>
+              <a:lnSpc>
+                <a:spcPct val="126900"/>
+              </a:lnSpc>
+              <a:spcBef>
+                <a:spcPts val="0"/>
+              </a:spcBef>
+              <a:spcAft>
+                <a:spcPts val="246"/>
+              </a:spcAft>
+            </a:pPr>
+            <a:r>
+              <a:rPr sz="1110" b="0" i="0">
                 <a:solidFill>
                   <a:srgbClr val="444444"/>
                 </a:solidFill>
                 <a:latin typeface="Iowan Old Style"/>
               </a:rPr>
-              <a:t>·  Arrastrar el contenido de la carpeta, no la carpeta.</a:t>
-            </a:r>
-          </a:p>
-          <a:p>
-            <a:pPr>
-              <a:lnSpc>
-                <a:spcPct val="140000"/>
-              </a:lnSpc>
-              <a:spcBef>
-                <a:spcPts val="0"/>
-              </a:spcBef>
-              <a:spcAft>
-                <a:spcPts val="500"/>
-              </a:spcAft>
-            </a:pPr>
-            <a:r>
-              <a:rPr sz="1450" b="0" i="0">
+              <a:t>☐  Commit changes</a:t>
+            </a:r>
+          </a:p>
+          <a:p>
+            <a:pPr>
+              <a:lnSpc>
+                <a:spcPct val="126900"/>
+              </a:lnSpc>
+              <a:spcBef>
+                <a:spcPts val="0"/>
+              </a:spcBef>
+              <a:spcAft>
+                <a:spcPts val="246"/>
+              </a:spcAft>
+            </a:pPr>
+            <a:r>
+              <a:rPr sz="1110" b="0" i="0">
                 <a:solidFill>
                   <a:srgbClr val="444444"/>
                 </a:solidFill>
                 <a:latin typeface="Iowan Old Style"/>
               </a:rPr>
-              <a:t>·  Commit changes.</a:t>
-            </a:r>
-          </a:p>
-          <a:p>
-            <a:pPr>
-              <a:lnSpc>
-                <a:spcPct val="140000"/>
-              </a:lnSpc>
-              <a:spcBef>
-                <a:spcPts val="0"/>
-              </a:spcBef>
-              <a:spcAft>
-                <a:spcPts val="500"/>
-              </a:spcAft>
-            </a:pPr>
-            <a:r>
-              <a:rPr sz="1450" b="0" i="0">
+              <a:t>☐  Settings → Pages → main → Save</a:t>
+            </a:r>
+          </a:p>
+          <a:p>
+            <a:pPr>
+              <a:lnSpc>
+                <a:spcPct val="126900"/>
+              </a:lnSpc>
+              <a:spcBef>
+                <a:spcPts val="0"/>
+              </a:spcBef>
+              <a:spcAft>
+                <a:spcPts val="246"/>
+              </a:spcAft>
+            </a:pPr>
+            <a:r>
+              <a:rPr sz="1110" b="0" i="0">
                 <a:solidFill>
                   <a:srgbClr val="444444"/>
                 </a:solidFill>
                 <a:latin typeface="Iowan Old Style"/>
               </a:rPr>
-              <a:t>·  Settings → Pages.</a:t>
-            </a:r>
-          </a:p>
-          <a:p>
-            <a:pPr>
-              <a:lnSpc>
-                <a:spcPct val="140000"/>
-              </a:lnSpc>
-              <a:spcBef>
-                <a:spcPts val="0"/>
-              </a:spcBef>
-              <a:spcAft>
-                <a:spcPts val="500"/>
-              </a:spcAft>
-            </a:pPr>
-            <a:r>
-              <a:rPr sz="1450" b="0" i="0">
+              <a:t>☐  La dirección apuntada en papel</a:t>
+            </a:r>
+          </a:p>
+          <a:p>
+            <a:pPr>
+              <a:lnSpc>
+                <a:spcPct val="117500"/>
+              </a:lnSpc>
+              <a:spcBef>
+                <a:spcPts val="1000"/>
+              </a:spcBef>
+              <a:spcAft>
+                <a:spcPts val="328"/>
+              </a:spcAft>
+            </a:pPr>
+            <a:r>
+              <a:rPr sz="950" b="0" i="0" spc="500">
+                <a:solidFill>
+                  <a:srgbClr val="8A7C14"/>
+                </a:solidFill>
+                <a:latin typeface="Menlo"/>
+              </a:rPr>
+              <a:t>PUEDES</a:t>
+            </a:r>
+          </a:p>
+          <a:p>
+            <a:pPr>
+              <a:lnSpc>
+                <a:spcPct val="126900"/>
+              </a:lnSpc>
+              <a:spcBef>
+                <a:spcPts val="0"/>
+              </a:spcBef>
+              <a:spcAft>
+                <a:spcPts val="246"/>
+              </a:spcAft>
+            </a:pPr>
+            <a:r>
+              <a:rPr sz="1110" b="0" i="0">
                 <a:solidFill>
                   <a:srgbClr val="444444"/>
                 </a:solidFill>
                 <a:latin typeface="Iowan Old Style"/>
               </a:rPr>
-              <a:t>·  Branch: main → Save.</a:t>
-            </a:r>
-          </a:p>
-          <a:p>
-            <a:pPr>
-              <a:lnSpc>
-                <a:spcPct val="140000"/>
-              </a:lnSpc>
-              <a:spcBef>
-                <a:spcPts val="0"/>
-              </a:spcBef>
-              <a:spcAft>
-                <a:spcPts val="500"/>
-              </a:spcAft>
-            </a:pPr>
-            <a:r>
-              <a:rPr sz="1450" b="0" i="0">
+              <a:t>☐  Abrirla en tu móvil</a:t>
+            </a:r>
+          </a:p>
+          <a:p>
+            <a:pPr>
+              <a:lnSpc>
+                <a:spcPct val="126900"/>
+              </a:lnSpc>
+              <a:spcBef>
+                <a:spcPts val="0"/>
+              </a:spcBef>
+              <a:spcAft>
+                <a:spcPts val="246"/>
+              </a:spcAft>
+            </a:pPr>
+            <a:r>
+              <a:rPr sz="1110" b="0" i="0">
                 <a:solidFill>
                   <a:srgbClr val="444444"/>
                 </a:solidFill>
                 <a:latin typeface="Iowan Old Style"/>
               </a:rPr>
-              <a:t>·  Esperar un minuto y recargar.</a:t>
-            </a:r>
-          </a:p>
-          <a:p>
-            <a:pPr>
-              <a:lnSpc>
-                <a:spcPct val="125000"/>
+              <a:t>☐  Comprobar que los enlaces funcionan publicados</a:t>
+            </a:r>
+          </a:p>
+          <a:p>
+            <a:pPr>
+              <a:lnSpc>
+                <a:spcPct val="126900"/>
+              </a:lnSpc>
+              <a:spcBef>
+                <a:spcPts val="0"/>
+              </a:spcBef>
+              <a:spcAft>
+                <a:spcPts val="246"/>
+              </a:spcAft>
+            </a:pPr>
+            <a:r>
+              <a:rPr sz="1110" b="0" i="0">
+                <a:solidFill>
+                  <a:srgbClr val="444444"/>
+                </a:solidFill>
+                <a:latin typeface="Iowan Old Style"/>
+              </a:rPr>
+              <a:t>☐  Comprobar que las imágenes se ven</a:t>
+            </a:r>
+          </a:p>
+          <a:p>
+            <a:pPr>
+              <a:lnSpc>
+                <a:spcPct val="126900"/>
+              </a:lnSpc>
+              <a:spcBef>
+                <a:spcPts val="0"/>
+              </a:spcBef>
+              <a:spcAft>
+                <a:spcPts val="246"/>
+              </a:spcAft>
+            </a:pPr>
+            <a:r>
+              <a:rPr sz="1110" b="0" i="0">
+                <a:solidFill>
+                  <a:srgbClr val="444444"/>
+                </a:solidFill>
+                <a:latin typeface="Iowan Old Style"/>
+              </a:rPr>
+              <a:t>☐  Poner un favicon</a:t>
+            </a:r>
+          </a:p>
+          <a:p>
+            <a:pPr>
+              <a:lnSpc>
+                <a:spcPct val="117500"/>
               </a:lnSpc>
               <a:spcBef>
                 <a:spcPts val="1000"/>
               </a:spcBef>
               <a:spcAft>
-                <a:spcPts val="300"/>
-              </a:spcAft>
-            </a:pPr>
-            <a:r>
-              <a:rPr sz="1000" b="0" i="0" spc="300">
+                <a:spcPts val="328"/>
+              </a:spcAft>
+            </a:pPr>
+            <a:r>
+              <a:rPr sz="950" b="0" i="0" spc="500">
+                <a:solidFill>
+                  <a:srgbClr val="8A7C14"/>
+                </a:solidFill>
+                <a:latin typeface="Menlo"/>
+              </a:rPr>
+              <a:t>PODRÍAS</a:t>
+            </a:r>
+          </a:p>
+          <a:p>
+            <a:pPr>
+              <a:lnSpc>
+                <a:spcPct val="126900"/>
+              </a:lnSpc>
+              <a:spcBef>
+                <a:spcPts val="0"/>
+              </a:spcBef>
+              <a:spcAft>
+                <a:spcPts val="246"/>
+              </a:spcAft>
+            </a:pPr>
+            <a:r>
+              <a:rPr sz="1110" b="0" i="0">
+                <a:solidFill>
+                  <a:srgbClr val="444444"/>
+                </a:solidFill>
+                <a:latin typeface="Iowan Old Style"/>
+              </a:rPr>
+              <a:t>☐  Una meta description por página</a:t>
+            </a:r>
+          </a:p>
+          <a:p>
+            <a:pPr>
+              <a:lnSpc>
+                <a:spcPct val="126900"/>
+              </a:lnSpc>
+              <a:spcBef>
+                <a:spcPts val="0"/>
+              </a:spcBef>
+              <a:spcAft>
+                <a:spcPts val="246"/>
+              </a:spcAft>
+            </a:pPr>
+            <a:r>
+              <a:rPr sz="1110" b="0" i="0">
+                <a:solidFill>
+                  <a:srgbClr val="444444"/>
+                </a:solidFill>
+                <a:latin typeface="Iowan Old Style"/>
+              </a:rPr>
+              <a:t>☐  Cloudflare Pages sobre el mismo repositorio</a:t>
+            </a:r>
+          </a:p>
+          <a:p>
+            <a:pPr>
+              <a:lnSpc>
+                <a:spcPct val="126900"/>
+              </a:lnSpc>
+              <a:spcBef>
+                <a:spcPts val="0"/>
+              </a:spcBef>
+              <a:spcAft>
+                <a:spcPts val="246"/>
+              </a:spcAft>
+            </a:pPr>
+            <a:r>
+              <a:rPr sz="1110" b="0" i="0">
+                <a:solidFill>
+                  <a:srgbClr val="444444"/>
+                </a:solidFill>
+                <a:latin typeface="Iowan Old Style"/>
+              </a:rPr>
+              <a:t>☐  Un dominio propio (en casa, con calma)</a:t>
+            </a:r>
+          </a:p>
+          <a:p>
+            <a:pPr>
+              <a:lnSpc>
+                <a:spcPct val="126900"/>
+              </a:lnSpc>
+              <a:spcBef>
+                <a:spcPts val="0"/>
+              </a:spcBef>
+              <a:spcAft>
+                <a:spcPts val="246"/>
+              </a:spcAft>
+            </a:pPr>
+            <a:r>
+              <a:rPr sz="1110" b="0" i="0">
+                <a:solidFill>
+                  <a:srgbClr val="444444"/>
+                </a:solidFill>
+                <a:latin typeface="Iowan Old Style"/>
+              </a:rPr>
+              <a:t>☐  Una página 404.html tuya</a:t>
+            </a:r>
+          </a:p>
+          <a:p>
+            <a:pPr>
+              <a:lnSpc>
+                <a:spcPct val="117500"/>
+              </a:lnSpc>
+              <a:spcBef>
+                <a:spcPts val="1000"/>
+              </a:spcBef>
+              <a:spcAft>
+                <a:spcPts val="246"/>
+              </a:spcAft>
+            </a:pPr>
+            <a:r>
+              <a:rPr sz="950" b="0" i="0" spc="300">
                 <a:solidFill>
                   <a:srgbClr val="8A8A8A"/>
                 </a:solidFill>
@@ -4873,17 +5071,17 @@
           <a:p>
             <a:pPr>
               <a:lnSpc>
-                <a:spcPct val="140000"/>
-              </a:lnSpc>
-              <a:spcBef>
-                <a:spcPts val="0"/>
-              </a:spcBef>
-              <a:spcAft>
-                <a:spcPts val="800"/>
-              </a:spcAft>
-            </a:pPr>
-            <a:r>
-              <a:rPr sz="1400" b="0" i="0">
+                <a:spcPct val="131600"/>
+              </a:lnSpc>
+              <a:spcBef>
+                <a:spcPts val="0"/>
+              </a:spcBef>
+              <a:spcAft>
+                <a:spcPts val="657"/>
+              </a:spcAft>
+            </a:pPr>
+            <a:r>
+              <a:rPr sz="1151" b="0" i="0">
                 <a:solidFill>
                   <a:srgbClr val="444444"/>
                 </a:solidFill>
@@ -4895,17 +5093,17 @@
           <a:p>
             <a:pPr>
               <a:lnSpc>
-                <a:spcPct val="125000"/>
+                <a:spcPct val="117500"/>
               </a:lnSpc>
               <a:spcBef>
                 <a:spcPts val="1000"/>
               </a:spcBef>
               <a:spcAft>
-                <a:spcPts val="300"/>
-              </a:spcAft>
-            </a:pPr>
-            <a:r>
-              <a:rPr sz="1000" b="0" i="0" spc="300">
+                <a:spcPts val="246"/>
+              </a:spcAft>
+            </a:pPr>
+            <a:r>
+              <a:rPr sz="950" b="0" i="0" spc="300">
                 <a:solidFill>
                   <a:srgbClr val="887000"/>
                 </a:solidFill>
@@ -4917,17 +5115,17 @@
           <a:p>
             <a:pPr>
               <a:lnSpc>
-                <a:spcPct val="140000"/>
-              </a:lnSpc>
-              <a:spcBef>
-                <a:spcPts val="0"/>
-              </a:spcBef>
-              <a:spcAft>
-                <a:spcPts val="800"/>
-              </a:spcAft>
-            </a:pPr>
-            <a:r>
-              <a:rPr sz="1400" b="1" i="0">
+                <a:spcPct val="131600"/>
+              </a:lnSpc>
+              <a:spcBef>
+                <a:spcPts val="0"/>
+              </a:spcBef>
+              <a:spcAft>
+                <a:spcPts val="657"/>
+              </a:spcAft>
+            </a:pPr>
+            <a:r>
+              <a:rPr sz="1151" b="1" i="0">
                 <a:solidFill>
                   <a:srgbClr val="0A0A0A"/>
                 </a:solidFill>
@@ -7930,11 +8128,11 @@
                 <a:spcPts val="0"/>
               </a:spcBef>
               <a:spcAft>
-                <a:spcPts val="668"/>
-              </a:spcAft>
-            </a:pPr>
-            <a:r>
-              <a:rPr sz="1113" b="0" i="0">
+                <a:spcPts val="780"/>
+              </a:spcAft>
+            </a:pPr>
+            <a:r>
+              <a:rPr sz="1301" b="0" i="0">
                 <a:solidFill>
                   <a:srgbClr val="444444"/>
                 </a:solidFill>
@@ -7946,347 +8144,369 @@
           <a:p>
             <a:pPr>
               <a:lnSpc>
+                <a:spcPct val="117500"/>
+              </a:lnSpc>
+              <a:spcBef>
+                <a:spcPts val="1000"/>
+              </a:spcBef>
+              <a:spcAft>
+                <a:spcPts val="346"/>
+              </a:spcAft>
+            </a:pPr>
+            <a:r>
+              <a:rPr sz="950" b="0" i="0" spc="500">
+                <a:solidFill>
+                  <a:srgbClr val="8A7C14"/>
+                </a:solidFill>
+                <a:latin typeface="Menlo"/>
+              </a:rPr>
+              <a:t>HAY QUE</a:t>
+            </a:r>
+          </a:p>
+          <a:p>
+            <a:pPr>
+              <a:lnSpc>
+                <a:spcPct val="126900"/>
+              </a:lnSpc>
+              <a:spcBef>
+                <a:spcPts val="0"/>
+              </a:spcBef>
+              <a:spcAft>
+                <a:spcPts val="260"/>
+              </a:spcAft>
+            </a:pPr>
+            <a:r>
+              <a:rPr sz="1170" b="0" i="0">
+                <a:solidFill>
+                  <a:srgbClr val="444444"/>
+                </a:solidFill>
+                <a:latin typeface="Iowan Old Style"/>
+              </a:rPr>
+              <a:t>☐  Cambiar algo que se note, en VS Code</a:t>
+            </a:r>
+          </a:p>
+          <a:p>
+            <a:pPr>
+              <a:lnSpc>
+                <a:spcPct val="126900"/>
+              </a:lnSpc>
+              <a:spcBef>
+                <a:spcPts val="0"/>
+              </a:spcBef>
+              <a:spcAft>
+                <a:spcPts val="260"/>
+              </a:spcAft>
+            </a:pPr>
+            <a:r>
+              <a:rPr sz="1170" b="0" i="0">
+                <a:solidFill>
+                  <a:srgbClr val="444444"/>
+                </a:solidFill>
+                <a:latin typeface="Iowan Old Style"/>
+              </a:rPr>
+              <a:t>☐  Guardar y comprobarlo en local</a:t>
+            </a:r>
+          </a:p>
+          <a:p>
+            <a:pPr>
+              <a:lnSpc>
+                <a:spcPct val="126900"/>
+              </a:lnSpc>
+              <a:spcBef>
+                <a:spcPts val="0"/>
+              </a:spcBef>
+              <a:spcAft>
+                <a:spcPts val="260"/>
+              </a:spcAft>
+            </a:pPr>
+            <a:r>
+              <a:rPr sz="1170" b="0" i="0">
+                <a:solidFill>
+                  <a:srgbClr val="444444"/>
+                </a:solidFill>
+                <a:latin typeface="Iowan Old Style"/>
+              </a:rPr>
+              <a:t>☐  Add file → Upload files</a:t>
+            </a:r>
+          </a:p>
+          <a:p>
+            <a:pPr>
+              <a:lnSpc>
+                <a:spcPct val="126900"/>
+              </a:lnSpc>
+              <a:spcBef>
+                <a:spcPts val="0"/>
+              </a:spcBef>
+              <a:spcAft>
+                <a:spcPts val="260"/>
+              </a:spcAft>
+            </a:pPr>
+            <a:r>
+              <a:rPr sz="1170" b="0" i="0">
+                <a:solidFill>
+                  <a:srgbClr val="444444"/>
+                </a:solidFill>
+                <a:latin typeface="Iowan Old Style"/>
+              </a:rPr>
+              <a:t>☐  Arrastrar el archivo encima del viejo</a:t>
+            </a:r>
+          </a:p>
+          <a:p>
+            <a:pPr>
+              <a:lnSpc>
+                <a:spcPct val="126900"/>
+              </a:lnSpc>
+              <a:spcBef>
+                <a:spcPts val="0"/>
+              </a:spcBef>
+              <a:spcAft>
+                <a:spcPts val="260"/>
+              </a:spcAft>
+            </a:pPr>
+            <a:r>
+              <a:rPr sz="1170" b="0" i="0">
+                <a:solidFill>
+                  <a:srgbClr val="444444"/>
+                </a:solidFill>
+                <a:latin typeface="Iowan Old Style"/>
+              </a:rPr>
+              <a:t>☐  Commit changes y ver el cambio online</a:t>
+            </a:r>
+          </a:p>
+          <a:p>
+            <a:pPr>
+              <a:lnSpc>
+                <a:spcPct val="126900"/>
+              </a:lnSpc>
+              <a:spcBef>
+                <a:spcPts val="0"/>
+              </a:spcBef>
+              <a:spcAft>
+                <a:spcPts val="260"/>
+              </a:spcAft>
+            </a:pPr>
+            <a:r>
+              <a:rPr sz="1170" b="0" i="0">
+                <a:solidFill>
+                  <a:srgbClr val="444444"/>
+                </a:solidFill>
+                <a:latin typeface="Iowan Old Style"/>
+              </a:rPr>
+              <a:t>☐  Repetirlo una segunda vez, sin mirar los pasos</a:t>
+            </a:r>
+          </a:p>
+          <a:p>
+            <a:pPr>
+              <a:lnSpc>
+                <a:spcPct val="117500"/>
+              </a:lnSpc>
+              <a:spcBef>
+                <a:spcPts val="1000"/>
+              </a:spcBef>
+              <a:spcAft>
+                <a:spcPts val="346"/>
+              </a:spcAft>
+            </a:pPr>
+            <a:r>
+              <a:rPr sz="950" b="0" i="0" spc="500">
+                <a:solidFill>
+                  <a:srgbClr val="8A7C14"/>
+                </a:solidFill>
+                <a:latin typeface="Menlo"/>
+              </a:rPr>
+              <a:t>PUEDES</a:t>
+            </a:r>
+          </a:p>
+          <a:p>
+            <a:pPr>
+              <a:lnSpc>
+                <a:spcPct val="126900"/>
+              </a:lnSpc>
+              <a:spcBef>
+                <a:spcPts val="0"/>
+              </a:spcBef>
+              <a:spcAft>
+                <a:spcPts val="260"/>
+              </a:spcAft>
+            </a:pPr>
+            <a:r>
+              <a:rPr sz="1170" b="0" i="0">
+                <a:solidFill>
+                  <a:srgbClr val="444444"/>
+                </a:solidFill>
+                <a:latin typeface="Iowan Old Style"/>
+              </a:rPr>
+              <a:t>☐  Añadir un proyecto nuevo entero</a:t>
+            </a:r>
+          </a:p>
+          <a:p>
+            <a:pPr>
+              <a:lnSpc>
+                <a:spcPct val="126900"/>
+              </a:lnSpc>
+              <a:spcBef>
+                <a:spcPts val="0"/>
+              </a:spcBef>
+              <a:spcAft>
+                <a:spcPts val="260"/>
+              </a:spcAft>
+            </a:pPr>
+            <a:r>
+              <a:rPr sz="1170" b="0" i="0">
+                <a:solidFill>
+                  <a:srgbClr val="444444"/>
+                </a:solidFill>
+                <a:latin typeface="Iowan Old Style"/>
+              </a:rPr>
+              <a:t>☐  Duplicar la carpeta con la fecha antes de tocar</a:t>
+            </a:r>
+          </a:p>
+          <a:p>
+            <a:pPr>
+              <a:lnSpc>
+                <a:spcPct val="126900"/>
+              </a:lnSpc>
+              <a:spcBef>
+                <a:spcPts val="0"/>
+              </a:spcBef>
+              <a:spcAft>
+                <a:spcPts val="260"/>
+              </a:spcAft>
+            </a:pPr>
+            <a:r>
+              <a:rPr sz="1170" b="0" i="0">
+                <a:solidFill>
+                  <a:srgbClr val="444444"/>
+                </a:solidFill>
+                <a:latin typeface="Iowan Old Style"/>
+              </a:rPr>
+              <a:t>☐  Mirar el History del archivo en GitHub</a:t>
+            </a:r>
+          </a:p>
+          <a:p>
+            <a:pPr>
+              <a:lnSpc>
+                <a:spcPct val="117500"/>
+              </a:lnSpc>
+              <a:spcBef>
+                <a:spcPts val="1000"/>
+              </a:spcBef>
+              <a:spcAft>
+                <a:spcPts val="346"/>
+              </a:spcAft>
+            </a:pPr>
+            <a:r>
+              <a:rPr sz="950" b="0" i="0" spc="500">
+                <a:solidFill>
+                  <a:srgbClr val="8A7C14"/>
+                </a:solidFill>
+                <a:latin typeface="Menlo"/>
+              </a:rPr>
+              <a:t>PODRÍAS</a:t>
+            </a:r>
+          </a:p>
+          <a:p>
+            <a:pPr>
+              <a:lnSpc>
+                <a:spcPct val="126900"/>
+              </a:lnSpc>
+              <a:spcBef>
+                <a:spcPts val="0"/>
+              </a:spcBef>
+              <a:spcAft>
+                <a:spcPts val="260"/>
+              </a:spcAft>
+            </a:pPr>
+            <a:r>
+              <a:rPr sz="1170" b="0" i="0">
+                <a:solidFill>
+                  <a:srgbClr val="444444"/>
+                </a:solidFill>
+                <a:latin typeface="Iowan Old Style"/>
+              </a:rPr>
+              <a:t>☐  Editar directamente en GitHub con el lápiz</a:t>
+            </a:r>
+          </a:p>
+          <a:p>
+            <a:pPr>
+              <a:lnSpc>
+                <a:spcPct val="126900"/>
+              </a:lnSpc>
+              <a:spcBef>
+                <a:spcPts val="0"/>
+              </a:spcBef>
+              <a:spcAft>
+                <a:spcPts val="260"/>
+              </a:spcAft>
+            </a:pPr>
+            <a:r>
+              <a:rPr sz="1170" b="0" i="0">
+                <a:solidFill>
+                  <a:srgbClr val="444444"/>
+                </a:solidFill>
+                <a:latin typeface="Iowan Old Style"/>
+              </a:rPr>
+              <a:t>☐  El panel Control de código fuente de VS Code</a:t>
+            </a:r>
+          </a:p>
+          <a:p>
+            <a:pPr>
+              <a:lnSpc>
+                <a:spcPct val="126900"/>
+              </a:lnSpc>
+              <a:spcBef>
+                <a:spcPts val="0"/>
+              </a:spcBef>
+              <a:spcAft>
+                <a:spcPts val="260"/>
+              </a:spcAft>
+            </a:pPr>
+            <a:r>
+              <a:rPr sz="1170" b="0" i="0">
+                <a:solidFill>
+                  <a:srgbClr val="444444"/>
+                </a:solidFill>
+                <a:latin typeface="Iowan Old Style"/>
+              </a:rPr>
+              <a:t>☐  Un README.md en el repositorio</a:t>
+            </a:r>
+          </a:p>
+          <a:p>
+            <a:pPr>
+              <a:lnSpc>
+                <a:spcPct val="117500"/>
+              </a:lnSpc>
+              <a:spcBef>
+                <a:spcPts val="1000"/>
+              </a:spcBef>
+              <a:spcAft>
+                <a:spcPts val="260"/>
+              </a:spcAft>
+            </a:pPr>
+            <a:r>
+              <a:rPr sz="950" b="0" i="0" spc="300">
+                <a:solidFill>
+                  <a:srgbClr val="8A8A8A"/>
+                </a:solidFill>
+                <a:latin typeface="Menlo"/>
+              </a:rPr>
+              <a:t>POR QUÉ ESTO Y NO OTRA COSA</a:t>
+            </a:r>
+          </a:p>
+          <a:p>
+            <a:pPr>
+              <a:lnSpc>
                 <a:spcPct val="131600"/>
               </a:lnSpc>
               <a:spcBef>
                 <a:spcPts val="0"/>
               </a:spcBef>
               <a:spcAft>
-                <a:spcPts val="371"/>
-              </a:spcAft>
-            </a:pPr>
-            <a:r>
-              <a:rPr sz="1076" b="0" i="0">
-                <a:solidFill>
-                  <a:srgbClr val="444444"/>
-                </a:solidFill>
-                <a:latin typeface="Iowan Old Style"/>
-              </a:rPr>
-              <a:t>☐  En VS Code, cambia algo que se note: una frase, un color, una imagen.</a:t>
-            </a:r>
-          </a:p>
-          <a:p>
-            <a:pPr>
-              <a:lnSpc>
-                <a:spcPct val="131600"/>
-              </a:lnSpc>
-              <a:spcBef>
-                <a:spcPts val="0"/>
-              </a:spcBef>
-              <a:spcAft>
-                <a:spcPts val="371"/>
-              </a:spcAft>
-            </a:pPr>
-            <a:r>
-              <a:rPr sz="1076" b="0" i="0">
-                <a:solidFill>
-                  <a:srgbClr val="444444"/>
-                </a:solidFill>
-                <a:latin typeface="Iowan Old Style"/>
-              </a:rPr>
-              <a:t>☐  Guarda.</a:t>
-            </a:r>
-          </a:p>
-          <a:p>
-            <a:pPr>
-              <a:lnSpc>
-                <a:spcPct val="131600"/>
-              </a:lnSpc>
-              <a:spcBef>
-                <a:spcPts val="0"/>
-              </a:spcBef>
-              <a:spcAft>
-                <a:spcPts val="371"/>
-              </a:spcAft>
-            </a:pPr>
-            <a:r>
-              <a:rPr sz="1076" b="0" i="0">
-                <a:solidFill>
-                  <a:srgbClr val="444444"/>
-                </a:solidFill>
-                <a:latin typeface="Iowan Old Style"/>
-              </a:rPr>
-              <a:t>☐  Ábrelo en tu navegador en local y comprueba que está bien.</a:t>
-            </a:r>
-          </a:p>
-          <a:p>
-            <a:pPr>
-              <a:lnSpc>
-                <a:spcPct val="131600"/>
-              </a:lnSpc>
-              <a:spcBef>
-                <a:spcPts val="0"/>
-              </a:spcBef>
-              <a:spcAft>
-                <a:spcPts val="371"/>
-              </a:spcAft>
-            </a:pPr>
-            <a:r>
-              <a:rPr sz="1076" b="0" i="0">
-                <a:solidFill>
-                  <a:srgbClr val="444444"/>
-                </a:solidFill>
-                <a:latin typeface="Iowan Old Style"/>
-              </a:rPr>
-              <a:t>☐  En GitHub: Add file → Upload files.</a:t>
-            </a:r>
-          </a:p>
-          <a:p>
-            <a:pPr>
-              <a:lnSpc>
-                <a:spcPct val="131600"/>
-              </a:lnSpc>
-              <a:spcBef>
-                <a:spcPts val="0"/>
-              </a:spcBef>
-              <a:spcAft>
-                <a:spcPts val="371"/>
-              </a:spcAft>
-            </a:pPr>
-            <a:r>
-              <a:rPr sz="1076" b="0" i="0">
-                <a:solidFill>
-                  <a:srgbClr val="444444"/>
-                </a:solidFill>
-                <a:latin typeface="Iowan Old Style"/>
-              </a:rPr>
-              <a:t>☐  Arrastra el archivo cambiado encima del que ya estaba.</a:t>
-            </a:r>
-          </a:p>
-          <a:p>
-            <a:pPr>
-              <a:lnSpc>
-                <a:spcPct val="131600"/>
-              </a:lnSpc>
-              <a:spcBef>
-                <a:spcPts val="0"/>
-              </a:spcBef>
-              <a:spcAft>
-                <a:spcPts val="371"/>
-              </a:spcAft>
-            </a:pPr>
-            <a:r>
-              <a:rPr sz="1076" b="0" i="0">
-                <a:solidFill>
-                  <a:srgbClr val="444444"/>
-                </a:solidFill>
-                <a:latin typeface="Iowan Old Style"/>
-              </a:rPr>
-              <a:t>☐  Commit changes.</a:t>
-            </a:r>
-          </a:p>
-          <a:p>
-            <a:pPr>
-              <a:lnSpc>
-                <a:spcPct val="131600"/>
-              </a:lnSpc>
-              <a:spcBef>
-                <a:spcPts val="0"/>
-              </a:spcBef>
-              <a:spcAft>
-                <a:spcPts val="371"/>
-              </a:spcAft>
-            </a:pPr>
-            <a:r>
-              <a:rPr sz="1076" b="0" i="0">
-                <a:solidFill>
-                  <a:srgbClr val="444444"/>
-                </a:solidFill>
-                <a:latin typeface="Iowan Old Style"/>
-              </a:rPr>
-              <a:t>☐  Espera un minuto, recarga tu web publicada y comprueba el cambio.</a:t>
-            </a:r>
-          </a:p>
-          <a:p>
-            <a:pPr>
-              <a:lnSpc>
-                <a:spcPct val="131600"/>
-              </a:lnSpc>
-              <a:spcBef>
-                <a:spcPts val="0"/>
-              </a:spcBef>
-              <a:spcAft>
-                <a:spcPts val="371"/>
-              </a:spcAft>
-            </a:pPr>
-            <a:r>
-              <a:rPr sz="1076" b="0" i="0">
-                <a:solidFill>
-                  <a:srgbClr val="444444"/>
-                </a:solidFill>
-                <a:latin typeface="Iowan Old Style"/>
-              </a:rPr>
-              <a:t>☐  Añade un proyecto nuevo a proyectos.html.</a:t>
-            </a:r>
-          </a:p>
-          <a:p>
-            <a:pPr>
-              <a:lnSpc>
-                <a:spcPct val="131600"/>
-              </a:lnSpc>
-              <a:spcBef>
-                <a:spcPts val="0"/>
-              </a:spcBef>
-              <a:spcAft>
-                <a:spcPts val="371"/>
-              </a:spcAft>
-            </a:pPr>
-            <a:r>
-              <a:rPr sz="1076" b="0" i="0">
-                <a:solidFill>
-                  <a:srgbClr val="444444"/>
-                </a:solidFill>
-                <a:latin typeface="Iowan Old Style"/>
-              </a:rPr>
-              <a:t>☐  Súbelo tú sola, sin mirar los pasos de arriba.</a:t>
-            </a:r>
-          </a:p>
-          <a:p>
-            <a:pPr>
-              <a:lnSpc>
-                <a:spcPct val="131600"/>
-              </a:lnSpc>
-              <a:spcBef>
-                <a:spcPts val="0"/>
-              </a:spcBef>
-              <a:spcAft>
-                <a:spcPts val="371"/>
-              </a:spcAft>
-            </a:pPr>
-            <a:r>
-              <a:rPr sz="1076" b="0" i="0">
-                <a:solidFill>
-                  <a:srgbClr val="444444"/>
-                </a:solidFill>
-                <a:latin typeface="Iowan Old Style"/>
-              </a:rPr>
-              <a:t>☐  Tengo mi dirección apuntada en papel.</a:t>
-            </a:r>
-          </a:p>
-          <a:p>
-            <a:pPr>
-              <a:lnSpc>
-                <a:spcPct val="131600"/>
-              </a:lnSpc>
-              <a:spcBef>
-                <a:spcPts val="0"/>
-              </a:spcBef>
-              <a:spcAft>
-                <a:spcPts val="371"/>
-              </a:spcAft>
-            </a:pPr>
-            <a:r>
-              <a:rPr sz="1076" b="0" i="0">
-                <a:solidFill>
-                  <a:srgbClr val="444444"/>
-                </a:solidFill>
-                <a:latin typeface="Iowan Old Style"/>
-              </a:rPr>
-              <a:t>☐  Tengo la carpeta guardada en mi ordenador.</a:t>
-            </a:r>
-          </a:p>
-          <a:p>
-            <a:pPr>
-              <a:lnSpc>
-                <a:spcPct val="131600"/>
-              </a:lnSpc>
-              <a:spcBef>
-                <a:spcPts val="0"/>
-              </a:spcBef>
-              <a:spcAft>
-                <a:spcPts val="371"/>
-              </a:spcAft>
-            </a:pPr>
-            <a:r>
-              <a:rPr sz="1076" b="0" i="0">
-                <a:solidFill>
-                  <a:srgbClr val="444444"/>
-                </a:solidFill>
-                <a:latin typeface="Iowan Old Style"/>
-              </a:rPr>
-              <a:t>☐  Sé entrar en mi cuenta de GitHub.</a:t>
-            </a:r>
-          </a:p>
-          <a:p>
-            <a:pPr>
-              <a:lnSpc>
-                <a:spcPct val="131600"/>
-              </a:lnSpc>
-              <a:spcBef>
-                <a:spcPts val="0"/>
-              </a:spcBef>
-              <a:spcAft>
-                <a:spcPts val="371"/>
-              </a:spcAft>
-            </a:pPr>
-            <a:r>
-              <a:rPr sz="1076" b="0" i="0">
-                <a:solidFill>
-                  <a:srgbClr val="444444"/>
-                </a:solidFill>
-                <a:latin typeface="Iowan Old Style"/>
-              </a:rPr>
-              <a:t>☐  He hecho el ciclo completo yo sola, al menos dos veces.</a:t>
-            </a:r>
-          </a:p>
-          <a:p>
-            <a:pPr>
-              <a:lnSpc>
-                <a:spcPct val="131600"/>
-              </a:lnSpc>
-              <a:spcBef>
-                <a:spcPts val="0"/>
-              </a:spcBef>
-              <a:spcAft>
-                <a:spcPts val="371"/>
-              </a:spcAft>
-            </a:pPr>
-            <a:r>
-              <a:rPr sz="1076" b="0" i="0">
-                <a:solidFill>
-                  <a:srgbClr val="444444"/>
-                </a:solidFill>
-                <a:latin typeface="Iowan Old Style"/>
-              </a:rPr>
-              <a:t>☐  Me llevo la guía y la chuleta.</a:t>
-            </a:r>
-          </a:p>
-          <a:p>
-            <a:pPr>
-              <a:lnSpc>
-                <a:spcPct val="117500"/>
-              </a:lnSpc>
-              <a:spcBef>
-                <a:spcPts val="1000"/>
-              </a:spcBef>
-              <a:spcAft>
-                <a:spcPts val="222"/>
-              </a:spcAft>
-            </a:pPr>
-            <a:r>
-              <a:rPr sz="950" b="0" i="0" spc="300">
-                <a:solidFill>
-                  <a:srgbClr val="8A8A8A"/>
-                </a:solidFill>
-                <a:latin typeface="Menlo"/>
-              </a:rPr>
-              <a:t>POR QUÉ ESTO Y NO OTRA COSA</a:t>
-            </a:r>
-          </a:p>
-          <a:p>
-            <a:pPr>
-              <a:lnSpc>
-                <a:spcPct val="131600"/>
-              </a:lnSpc>
-              <a:spcBef>
-                <a:spcPts val="0"/>
-              </a:spcBef>
-              <a:spcAft>
-                <a:spcPts val="593"/>
-              </a:spcAft>
-            </a:pPr>
-            <a:r>
-              <a:rPr sz="1039" b="0" i="0">
+                <a:spcPts val="693"/>
+              </a:spcAft>
+            </a:pPr>
+            <a:r>
+              <a:rPr sz="1214" b="0" i="0">
                 <a:solidFill>
                   <a:srgbClr val="444444"/>
                 </a:solidFill>

</xml_diff>